<commit_message>
fix: factory boy + faker
</commit_message>
<xml_diff>
--- a/docs/slides.pptx
+++ b/docs/slides.pptx
@@ -3407,7 +3407,7 @@
                 <a:ea typeface="Trebuchet MS" pitchFamily="34" charset="-122"/>
                 <a:cs typeface="Trebuchet MS" pitchFamily="34" charset="-120"/>
               </a:rPr>
-              <a:t>Test piramidi: 290 test fonksiyonu</a:t>
+              <a:t>Test piramidi: 306 test fonksiyonu</a:t>
             </a:r>
             <a:endParaRPr lang="en-US" sz="3200" dirty="0"/>
           </a:p>
@@ -3422,7 +3422,7 @@
         <p:spPr>
           <a:xfrm>
             <a:off x="548640" y="1920240"/>
-            <a:ext cx="2630359" cy="868680"/>
+            <a:ext cx="2598157" cy="868680"/>
           </a:xfrm>
           <a:prstGeom prst="roundRect">
             <a:avLst>
@@ -3444,7 +3444,7 @@
         <p:spPr>
           <a:xfrm>
             <a:off x="777240" y="1920240"/>
-            <a:ext cx="2356039" cy="868680"/>
+            <a:ext cx="2323837" cy="868680"/>
           </a:xfrm>
           <a:prstGeom prst="rect">
             <a:avLst/>
@@ -3496,7 +3496,7 @@
         </p:nvSpPr>
         <p:spPr>
           <a:xfrm>
-            <a:off x="3407599" y="1920240"/>
+            <a:off x="3375397" y="1920240"/>
             <a:ext cx="3840480" cy="868680"/>
           </a:xfrm>
           <a:prstGeom prst="rect">
@@ -3521,7 +3521,7 @@
                 <a:ea typeface="Calibri" pitchFamily="34" charset="-122"/>
                 <a:cs typeface="Calibri" pitchFamily="34" charset="-120"/>
               </a:rPr>
-              <a:t>Playwright · API + UI akışları (3 dosya)</a:t>
+              <a:t>Playwright · API + UI akışları (CI'da)</a:t>
             </a:r>
             <a:endParaRPr lang="en-US" sz="1250" dirty="0"/>
           </a:p>
@@ -3596,7 +3596,7 @@
                 <a:ea typeface="Trebuchet MS" pitchFamily="34" charset="-122"/>
                 <a:cs typeface="Trebuchet MS" pitchFamily="34" charset="-120"/>
               </a:rPr>
-              <a:t>141</a:t>
+              <a:t>145</a:t>
             </a:r>
             <a:endParaRPr lang="en-US" sz="1800" dirty="0"/>
           </a:p>
@@ -3650,7 +3650,7 @@
         <p:spPr>
           <a:xfrm>
             <a:off x="548640" y="4297680"/>
-            <a:ext cx="7252943" cy="868680"/>
+            <a:ext cx="7638078" cy="868680"/>
           </a:xfrm>
           <a:prstGeom prst="roundRect">
             <a:avLst>
@@ -3672,7 +3672,7 @@
         <p:spPr>
           <a:xfrm>
             <a:off x="777240" y="4297680"/>
-            <a:ext cx="6978623" cy="868680"/>
+            <a:ext cx="7363758" cy="868680"/>
           </a:xfrm>
           <a:prstGeom prst="rect">
             <a:avLst/>
@@ -3710,7 +3710,7 @@
                 <a:ea typeface="Trebuchet MS" pitchFamily="34" charset="-122"/>
                 <a:cs typeface="Trebuchet MS" pitchFamily="34" charset="-120"/>
               </a:rPr>
-              <a:t>124</a:t>
+              <a:t>136</a:t>
             </a:r>
             <a:endParaRPr lang="en-US" sz="1800" dirty="0"/>
           </a:p>
@@ -3724,7 +3724,7 @@
         </p:nvSpPr>
         <p:spPr>
           <a:xfrm>
-            <a:off x="8030183" y="4297680"/>
+            <a:off x="8415318" y="4297680"/>
             <a:ext cx="3840480" cy="868680"/>
           </a:xfrm>
           <a:prstGeom prst="rect">
@@ -3749,7 +3749,7 @@
                 <a:ea typeface="Calibri" pitchFamily="34" charset="-122"/>
                 <a:cs typeface="Calibri" pitchFamily="34" charset="-120"/>
               </a:rPr>
-              <a:t>servisler · yardımcılar · şema doğrulama</a:t>
+              <a:t>servisler · yardımcılar · şema · factory</a:t>
             </a:r>
             <a:endParaRPr lang="en-US" sz="1250" dirty="0"/>
           </a:p>
@@ -3957,7 +3957,7 @@
                 <a:ea typeface="Calibri" pitchFamily="34" charset="-122"/>
                 <a:cs typeface="Calibri" pitchFamily="34" charset="-120"/>
               </a:rPr>
-              <a:t>277 test geçer · 0 hata</a:t>
+              <a:t>293 test geçer · 0 hata</a:t>
             </a:r>
             <a:endParaRPr lang="en-US" sz="1300" dirty="0"/>
           </a:p>
@@ -3999,7 +3999,7 @@
                 <a:ea typeface="Calibri" pitchFamily="34" charset="-122"/>
                 <a:cs typeface="Calibri" pitchFamily="34" charset="-120"/>
               </a:rPr>
-              <a:t>Factory Boy + Faker ile test verisi · Postman 7 istek → Newman · öne çıkan: 409 çift-rezervasyon, iptal sonrası müsaitlik, ownership, ödeme/iletişim kalıcılığı.</a:t>
+              <a:t>Factory Boy + Faker (Room/Booking/Hotel/User) suite genelinde · Postman 7 istek → Newman · öne çıkan: 409 çakışma, iptal sonrası müsaitlik, ownership, kalıcılık.</a:t>
             </a:r>
             <a:endParaRPr lang="en-US" sz="1300" dirty="0"/>
           </a:p>
@@ -4243,7 +4243,7 @@
               <a:buNone/>
             </a:pPr>
             <a:r>
-              <a:rPr lang="en-US" sz="1250" dirty="0">
+              <a:rPr lang="en-US" sz="1200" dirty="0">
                 <a:solidFill>
                   <a:srgbClr val="CADCFC"/>
                 </a:solidFill>
@@ -4253,7 +4253,7 @@
               </a:rPr>
               <a:t>ruff (E·F·I)</a:t>
             </a:r>
-            <a:endParaRPr lang="en-US" sz="1250" dirty="0"/>
+            <a:endParaRPr lang="en-US" sz="1200" dirty="0"/>
           </a:p>
         </p:txBody>
       </p:sp>
@@ -4424,7 +4424,7 @@
               <a:buNone/>
             </a:pPr>
             <a:r>
-              <a:rPr lang="en-US" sz="1250" dirty="0">
+              <a:rPr lang="en-US" sz="1200" dirty="0">
                 <a:solidFill>
                   <a:srgbClr val="CADCFC"/>
                 </a:solidFill>
@@ -4434,7 +4434,7 @@
               </a:rPr>
               <a:t>pytest</a:t>
             </a:r>
-            <a:endParaRPr lang="en-US" sz="1250" dirty="0"/>
+            <a:endParaRPr lang="en-US" sz="1200" dirty="0"/>
           </a:p>
           <a:p>
             <a:pPr algn="ctr" indent="0" marL="0">
@@ -4444,7 +4444,7 @@
               <a:buNone/>
             </a:pPr>
             <a:r>
-              <a:rPr lang="en-US" sz="1250" dirty="0">
+              <a:rPr lang="en-US" sz="1200" dirty="0">
                 <a:solidFill>
                   <a:srgbClr val="CADCFC"/>
                 </a:solidFill>
@@ -4454,7 +4454,7 @@
               </a:rPr>
               <a:t>cov ≥70%</a:t>
             </a:r>
-            <a:endParaRPr lang="en-US" sz="1250" dirty="0"/>
+            <a:endParaRPr lang="en-US" sz="1200" dirty="0"/>
           </a:p>
         </p:txBody>
       </p:sp>
@@ -4625,7 +4625,7 @@
               <a:buNone/>
             </a:pPr>
             <a:r>
-              <a:rPr lang="en-US" sz="1250" dirty="0">
+              <a:rPr lang="en-US" sz="1200" dirty="0">
                 <a:solidFill>
                   <a:srgbClr val="CADCFC"/>
                 </a:solidFill>
@@ -4635,7 +4635,7 @@
               </a:rPr>
               <a:t>docker</a:t>
             </a:r>
-            <a:endParaRPr lang="en-US" sz="1250" dirty="0"/>
+            <a:endParaRPr lang="en-US" sz="1200" dirty="0"/>
           </a:p>
           <a:p>
             <a:pPr algn="ctr" indent="0" marL="0">
@@ -4645,7 +4645,7 @@
               <a:buNone/>
             </a:pPr>
             <a:r>
-              <a:rPr lang="en-US" sz="1250" dirty="0">
+              <a:rPr lang="en-US" sz="1200" dirty="0">
                 <a:solidFill>
                   <a:srgbClr val="CADCFC"/>
                 </a:solidFill>
@@ -4655,7 +4655,7 @@
               </a:rPr>
               <a:t>multi-stage</a:t>
             </a:r>
-            <a:endParaRPr lang="en-US" sz="1250" dirty="0"/>
+            <a:endParaRPr lang="en-US" sz="1200" dirty="0"/>
           </a:p>
         </p:txBody>
       </p:sp>
@@ -4826,7 +4826,7 @@
               <a:buNone/>
             </a:pPr>
             <a:r>
-              <a:rPr lang="en-US" sz="1250" dirty="0">
+              <a:rPr lang="en-US" sz="1200" dirty="0">
                 <a:solidFill>
                   <a:srgbClr val="0F2C44"/>
                 </a:solidFill>
@@ -4836,7 +4836,7 @@
               </a:rPr>
               <a:t>Minikube</a:t>
             </a:r>
-            <a:endParaRPr lang="en-US" sz="1250" dirty="0"/>
+            <a:endParaRPr lang="en-US" sz="1200" dirty="0"/>
           </a:p>
           <a:p>
             <a:pPr algn="ctr" indent="0" marL="0">
@@ -4846,7 +4846,7 @@
               <a:buNone/>
             </a:pPr>
             <a:r>
-              <a:rPr lang="en-US" sz="1250" dirty="0">
+              <a:rPr lang="en-US" sz="1200" dirty="0">
                 <a:solidFill>
                   <a:srgbClr val="0F2C44"/>
                 </a:solidFill>
@@ -4856,7 +4856,7 @@
               </a:rPr>
               <a:t>kubectl apply</a:t>
             </a:r>
-            <a:endParaRPr lang="en-US" sz="1250" dirty="0"/>
+            <a:endParaRPr lang="en-US" sz="1200" dirty="0"/>
           </a:p>
         </p:txBody>
       </p:sp>
@@ -5027,7 +5027,7 @@
               <a:buNone/>
             </a:pPr>
             <a:r>
-              <a:rPr lang="en-US" sz="1250" dirty="0">
+              <a:rPr lang="en-US" sz="1200" dirty="0">
                 <a:solidFill>
                   <a:srgbClr val="CADCFC"/>
                 </a:solidFill>
@@ -5035,9 +5035,9 @@
                 <a:ea typeface="Calibri" pitchFamily="34" charset="-122"/>
                 <a:cs typeface="Calibri" pitchFamily="34" charset="-120"/>
               </a:rPr>
-              <a:t>/health</a:t>
-            </a:r>
-            <a:endParaRPr lang="en-US" sz="1250" dirty="0"/>
+              <a:t>/health · Newman</a:t>
+            </a:r>
+            <a:endParaRPr lang="en-US" sz="1200" dirty="0"/>
           </a:p>
           <a:p>
             <a:pPr algn="ctr" indent="0" marL="0">
@@ -5047,7 +5047,7 @@
               <a:buNone/>
             </a:pPr>
             <a:r>
-              <a:rPr lang="en-US" sz="1250" dirty="0">
+              <a:rPr lang="en-US" sz="1200" dirty="0">
                 <a:solidFill>
                   <a:srgbClr val="CADCFC"/>
                 </a:solidFill>
@@ -5055,9 +5055,9 @@
                 <a:ea typeface="Calibri" pitchFamily="34" charset="-122"/>
                 <a:cs typeface="Calibri" pitchFamily="34" charset="-120"/>
               </a:rPr>
-              <a:t>Newman</a:t>
-            </a:r>
-            <a:endParaRPr lang="en-US" sz="1250" dirty="0"/>
+              <a:t>E2E · k6</a:t>
+            </a:r>
+            <a:endParaRPr lang="en-US" sz="1200" dirty="0"/>
           </a:p>
         </p:txBody>
       </p:sp>
@@ -5153,7 +5153,7 @@
                 <a:ea typeface="Calibri" pitchFamily="34" charset="-122"/>
                 <a:cs typeface="Calibri" pitchFamily="34" charset="-120"/>
               </a:rPr>
-              <a:t>Tüm repo ruff lint temiz · 277 test yeşil · build &amp; deploy demoda canlı gösterilir.</a:t>
+              <a:t>Tüm test piramidi otomatik: 293 unit+integration + 25 E2E (Playwright) + k6 p95&lt;500 regresyon kapısı · ruff lint temiz.</a:t>
             </a:r>
             <a:endParaRPr lang="en-US" sz="1300" dirty="0"/>
           </a:p>
@@ -6234,7 +6234,7 @@
                 <a:ea typeface="Trebuchet MS" pitchFamily="34" charset="-122"/>
                 <a:cs typeface="Trebuchet MS" pitchFamily="34" charset="-120"/>
               </a:rPr>
-              <a:t>277</a:t>
+              <a:t>293</a:t>
             </a:r>
             <a:endParaRPr lang="en-US" sz="3800" dirty="0"/>
           </a:p>
@@ -6342,7 +6342,7 @@
                 <a:ea typeface="Trebuchet MS" pitchFamily="34" charset="-122"/>
                 <a:cs typeface="Trebuchet MS" pitchFamily="34" charset="-120"/>
               </a:rPr>
-              <a:t>290</a:t>
+              <a:t>306</a:t>
             </a:r>
             <a:endParaRPr lang="en-US" sz="3800" dirty="0"/>
           </a:p>
@@ -6492,7 +6492,7 @@
                 <a:ea typeface="Calibri" pitchFamily="34" charset="-122"/>
                 <a:cs typeface="Calibri" pitchFamily="34" charset="-120"/>
               </a:rPr>
-              <a:t>k6 p95 latency (&lt;500 ms)</a:t>
+              <a:t>k6 p95 (&lt;500, CI kapısı)</a:t>
             </a:r>
             <a:endParaRPr lang="en-US" sz="1300" dirty="0"/>
           </a:p>
@@ -6666,7 +6666,7 @@
                 <a:ea typeface="Trebuchet MS" pitchFamily="34" charset="-122"/>
                 <a:cs typeface="Trebuchet MS" pitchFamily="34" charset="-120"/>
               </a:rPr>
-              <a:t>0%</a:t>
+              <a:t>25</a:t>
             </a:r>
             <a:endParaRPr lang="en-US" sz="3800" dirty="0"/>
           </a:p>
@@ -6708,7 +6708,7 @@
                 <a:ea typeface="Calibri" pitchFamily="34" charset="-122"/>
                 <a:cs typeface="Calibri" pitchFamily="34" charset="-120"/>
               </a:rPr>
-              <a:t>k6 hata oranı · 4756 istek</a:t>
+              <a:t>Playwright E2E (CI'da)</a:t>
             </a:r>
             <a:endParaRPr lang="en-US" sz="1300" dirty="0"/>
           </a:p>
@@ -7160,7 +7160,7 @@
                 <a:ea typeface="Calibri" pitchFamily="34" charset="-122"/>
                 <a:cs typeface="Calibri" pitchFamily="34" charset="-120"/>
               </a:rPr>
-              <a:t>Birim testte async/senkron mock ayrımı — AsyncMock'ın .add()'te coroutine sızdırması.
+              <a:t>Factory Boy + Faker — gerçekçi, bakımı kolay test verisi suite genelinde.
 </a:t>
             </a:r>
             <a:pPr indent="0" marL="0">
@@ -7287,7 +7287,7 @@
                 <a:ea typeface="Calibri" pitchFamily="34" charset="-122"/>
                 <a:cs typeface="Calibri" pitchFamily="34" charset="-120"/>
               </a:rPr>
-              <a:t>Test gürültüsü: OpenTelemetry'yi test ortamında kapatıp temiz çıktı almak.
+              <a:t>Test gürültüsü/dayanıklılık: OTel'i test'te kapatmak, LocalStack'i Docker yoksa skip etmek.
 </a:t>
             </a:r>
             <a:pPr indent="0" marL="0">
@@ -7308,7 +7308,7 @@
                 <a:ea typeface="Calibri" pitchFamily="34" charset="-122"/>
                 <a:cs typeface="Calibri" pitchFamily="34" charset="-120"/>
               </a:rPr>
-              <a:t>CI'da gerçek Minikube deploy: app açılışta migration koştuğu için PG'yi cluster içinde ayağa kaldırmak.</a:t>
+              <a:t>CI'da gerçek Minikube deploy + E2E/k6 otomasyonu (canlı stack + seed).</a:t>
             </a:r>
             <a:endParaRPr lang="en-US" sz="1600" dirty="0"/>
           </a:p>

</xml_diff>